<commit_message>
new classes on ffp and bosman case
</commit_message>
<xml_diff>
--- a/lectures/L9.pptx
+++ b/lectures/L9.pptx
@@ -21,6 +21,7 @@
     <p:sldId id="285" r:id="rId12"/>
     <p:sldId id="288" r:id="rId13"/>
     <p:sldId id="289" r:id="rId14"/>
+    <p:sldId id="295" r:id="rId23"/>
     <p:sldId id="290" r:id="rId15"/>
     <p:sldId id="286" r:id="rId16"/>
     <p:sldId id="287" r:id="rId17"/>
@@ -28,8 +29,11 @@
     <p:sldId id="291" r:id="rId19"/>
     <p:sldId id="292" r:id="rId20"/>
     <p:sldId id="293" r:id="rId21"/>
+    <p:sldId id="296" r:id="rId33"/>
     <p:sldId id="294" r:id="rId22"/>
-    <p:sldId id="295" r:id="rId23"/>
+    <p:sldId id="299" r:id="rId36"/>
+    <p:sldId id="297" r:id="rId34"/>
+    <p:sldId id="298" r:id="rId35"/>
   </p:sldIdLst>
   <p:sldSz cx="9144000" cy="5715000" type="screen16x10"/>
   <p:notesSz cx="6858000" cy="9144000"/>
@@ -13729,6 +13733,206 @@
           <a:chExt cx="0" cy="0"/>
         </a:xfrm>
       </p:grpSpPr>
+      <mc:AlternateContent xmlns:mc="http://schemas.openxmlformats.org/markup-compatibility/2006" xmlns:a14="http://schemas.microsoft.com/office/drawing/2010/main">
+        <mc:Choice Requires="a14">
+          <p:sp>
+            <p:nvSpPr>
+              <p:cNvPr id="2" name="Title 1">
+                <a:extLst>
+                  <a:ext uri="{FF2B5EF4-FFF2-40B4-BE49-F238E27FC236}">
+                    <a16:creationId xmlns:a16="http://schemas.microsoft.com/office/drawing/2014/main" id="{B21B660B-1E0B-4D01-87CB-4B7D98486F54}"/>
+                  </a:ext>
+                </a:extLst>
+              </p:cNvPr>
+              <p:cNvSpPr>
+                <a:spLocks noGrp="1"/>
+              </p:cNvSpPr>
+              <p:nvPr>
+                <p:ph type="title"/>
+              </p:nvPr>
+            </p:nvSpPr>
+            <p:spPr/>
+            <p:txBody>
+              <a:bodyPr/>
+              <a:lstStyle/>
+              <a:p>
+                <a:pPr algn="ctr"/>
+                <a:r>
+                  <a:rPr lang="it-IT" dirty="0"/>
+                  <a:t>Inflation rate (</a:t>
+                </a:r>
+                <a14:m>
+                  <m:oMath xmlns:m="http://schemas.openxmlformats.org/officeDocument/2006/math">
+                    <m:r>
+                      <a:rPr lang="nb-NO" b="0" i="1" smtClean="0">
+                        <a:latin typeface="Cambria Math" panose="02040503050406030204" pitchFamily="18" charset="0"/>
+                      </a:rPr>
+                      <m:t>𝜋</m:t>
+                    </m:r>
+                    <m:r>
+                      <a:rPr lang="nb-NO" b="0" i="1" smtClean="0">
+                        <a:latin typeface="Cambria Math" panose="02040503050406030204" pitchFamily="18" charset="0"/>
+                      </a:rPr>
+                      <m:t>)</m:t>
+                    </m:r>
+                  </m:oMath>
+                </a14:m>
+                <a:r>
+                  <a:rPr lang="en-US" dirty="0"/>
+                  <a:t> Norway</a:t>
+                </a:r>
+              </a:p>
+            </p:txBody>
+          </p:sp>
+        </mc:Choice>
+        <mc:Fallback xmlns="">
+          <p:sp>
+            <p:nvSpPr>
+              <p:cNvPr id="2" name="Title 1">
+                <a:extLst>
+                  <a:ext uri="{FF2B5EF4-FFF2-40B4-BE49-F238E27FC236}">
+                    <a16:creationId xmlns:a16="http://schemas.microsoft.com/office/drawing/2014/main" id="{B21B660B-1E0B-4D01-87CB-4B7D98486F54}"/>
+                  </a:ext>
+                </a:extLst>
+              </p:cNvPr>
+              <p:cNvSpPr>
+                <a:spLocks noGrp="1" noRot="1" noChangeAspect="1" noMove="1" noResize="1" noEditPoints="1" noAdjustHandles="1" noChangeArrowheads="1" noChangeShapeType="1" noTextEdit="1"/>
+              </p:cNvSpPr>
+              <p:nvPr>
+                <p:ph type="title"/>
+              </p:nvPr>
+            </p:nvSpPr>
+            <p:spPr>
+              <a:blipFill>
+                <a:blip r:embed="rId2"/>
+                <a:stretch>
+                  <a:fillRect/>
+                </a:stretch>
+              </a:blipFill>
+            </p:spPr>
+            <p:txBody>
+              <a:bodyPr/>
+              <a:lstStyle/>
+              <a:p>
+                <a:r>
+                  <a:rPr lang="en-US">
+                    <a:noFill/>
+                  </a:rPr>
+                  <a:t> </a:t>
+                </a:r>
+              </a:p>
+            </p:txBody>
+          </p:sp>
+        </mc:Fallback>
+      </mc:AlternateContent>
+      <p:sp>
+        <p:nvSpPr>
+          <p:cNvPr id="3" name="Content Placeholder 2">
+            <a:extLst>
+              <a:ext uri="{FF2B5EF4-FFF2-40B4-BE49-F238E27FC236}">
+                <a16:creationId xmlns:a16="http://schemas.microsoft.com/office/drawing/2014/main" id="{6285D6BC-086B-479F-9F72-15CA362D665B}"/>
+              </a:ext>
+            </a:extLst>
+          </p:cNvPr>
+          <p:cNvSpPr>
+            <a:spLocks noGrp="1"/>
+          </p:cNvSpPr>
+          <p:nvPr>
+            <p:ph idx="1"/>
+          </p:nvPr>
+        </p:nvSpPr>
+        <p:spPr/>
+        <p:txBody>
+          <a:bodyPr>
+            <a:normAutofit/>
+          </a:bodyPr>
+          <a:lstStyle/>
+          <a:p>
+            <a:r>
+              <a:rPr lang="en-US" sz="2000" dirty="0"/>
+              <a:t>Inflation is a general increase in the price level of goods and services in the economy over time</a:t>
+            </a:r>
+          </a:p>
+          <a:p>
+            <a:pPr lvl="1"/>
+            <a:r>
+              <a:rPr lang="en-US" sz="1800" dirty="0"/>
+              <a:t>Inflation </a:t>
+            </a:r>
+            <a:r>
+              <a:rPr lang="en-US" sz="1800" dirty="0">
+                <a:sym typeface="Wingdings" panose="05000000000000000000" pitchFamily="2" charset="2"/>
+              </a:rPr>
+              <a:t>   future price of goods </a:t>
+            </a:r>
+            <a:endParaRPr lang="en-US" sz="1800" dirty="0"/>
+          </a:p>
+          <a:p>
+            <a:r>
+              <a:rPr lang="en-US" sz="2000" dirty="0"/>
+              <a:t>September 2021 4.1% - August 2021 3.4%</a:t>
+            </a:r>
+          </a:p>
+          <a:p>
+            <a:pPr lvl="1"/>
+            <a:r>
+              <a:rPr lang="en-US" sz="2000" dirty="0"/>
+              <a:t>Highest inflation rate since July 2016</a:t>
+            </a:r>
+          </a:p>
+          <a:p>
+            <a:pPr lvl="2"/>
+            <a:r>
+              <a:rPr lang="en-US" sz="2000" dirty="0"/>
+              <a:t>Faster rise in prices of housing and utilities </a:t>
+            </a:r>
+          </a:p>
+          <a:p>
+            <a:pPr lvl="2"/>
+            <a:r>
+              <a:rPr lang="en-US" sz="2000" dirty="0"/>
+              <a:t>Furnishing household equipment and routine maintenance</a:t>
+            </a:r>
+          </a:p>
+          <a:p>
+            <a:pPr lvl="2"/>
+            <a:r>
+              <a:rPr lang="en-US" sz="2000" dirty="0"/>
+              <a:t>Recreation and culture</a:t>
+            </a:r>
+          </a:p>
+        </p:txBody>
+      </p:sp>
+    </p:spTree>
+    <p:extLst>
+      <p:ext uri="{BB962C8B-B14F-4D97-AF65-F5344CB8AC3E}">
+        <p14:creationId xmlns:p14="http://schemas.microsoft.com/office/powerpoint/2010/main" val="2310254051"/>
+      </p:ext>
+    </p:extLst>
+  </p:cSld>
+  <p:clrMapOvr>
+    <a:masterClrMapping/>
+  </p:clrMapOvr>
+</p:sld>
+</file>
+
+<file path=ppt/slides/slide11.xml><?xml version="1.0" encoding="utf-8"?>
+<p:sld xmlns:a="http://schemas.openxmlformats.org/drawingml/2006/main" xmlns:r="http://schemas.openxmlformats.org/officeDocument/2006/relationships" xmlns:p="http://schemas.openxmlformats.org/presentationml/2006/main">
+  <p:cSld>
+    <p:spTree>
+      <p:nvGrpSpPr>
+        <p:cNvPr id="1" name=""/>
+        <p:cNvGrpSpPr/>
+        <p:nvPr/>
+      </p:nvGrpSpPr>
+      <p:grpSpPr>
+        <a:xfrm>
+          <a:off x="0" y="0"/>
+          <a:ext cx="0" cy="0"/>
+          <a:chOff x="0" y="0"/>
+          <a:chExt cx="0" cy="0"/>
+        </a:xfrm>
+      </p:grpSpPr>
       <p:pic>
         <p:nvPicPr>
           <p:cNvPr id="5" name="Picture 4" descr="Text&#10;&#10;Description automatically generated with medium confidence">
@@ -13772,7 +13976,7 @@
 </p:sld>
 </file>
 
-<file path=ppt/slides/slide11.xml><?xml version="1.0" encoding="utf-8"?>
+<file path=ppt/slides/slide12.xml><?xml version="1.0" encoding="utf-8"?>
 <p:sld xmlns:a="http://schemas.openxmlformats.org/drawingml/2006/main" xmlns:r="http://schemas.openxmlformats.org/officeDocument/2006/relationships" xmlns:p="http://schemas.openxmlformats.org/presentationml/2006/main">
   <p:cSld>
     <p:spTree>
@@ -13850,23 +14054,15 @@
           <a:p>
             <a:pPr lvl="1"/>
             <a:r>
-              <a:rPr lang="it-IT" dirty="0"/>
-              <a:t>Future cash flow </a:t>
-            </a:r>
-            <a:r>
-              <a:rPr lang="it-IT" dirty="0">
-                <a:sym typeface="Wingdings" panose="05000000000000000000" pitchFamily="2" charset="2"/>
-              </a:rPr>
-              <a:t> FV </a:t>
+              <a:rPr lang="en-US" dirty="0"/>
+              <a:t>Money you receive in the future (an incoming cash flow) increases your future value</a:t>
             </a:r>
           </a:p>
           <a:p>
             <a:pPr lvl="1"/>
             <a:r>
-              <a:rPr lang="it-IT" dirty="0">
-                <a:sym typeface="Wingdings" panose="05000000000000000000" pitchFamily="2" charset="2"/>
-              </a:rPr>
-              <a:t>Future  payment  FV </a:t>
+              <a:rPr lang="en-US" dirty="0"/>
+              <a:t>Money you pay out in the future (an outgoing payment) decreases your future value</a:t>
             </a:r>
           </a:p>
           <a:p>
@@ -13937,58 +14133,7 @@
         </p:txBody>
       </p:sp>
       <mc:AlternateContent xmlns:mc="http://schemas.openxmlformats.org/markup-compatibility/2006">
-        <mc:Choice xmlns:pslz="http://schemas.microsoft.com/office/powerpoint/2016/slidezoom" Requires="pslz">
-          <p:graphicFrame>
-            <p:nvGraphicFramePr>
-              <p:cNvPr id="5" name="Slide Zoom 4">
-                <a:extLst>
-                  <a:ext uri="{FF2B5EF4-FFF2-40B4-BE49-F238E27FC236}">
-                    <a16:creationId xmlns:a16="http://schemas.microsoft.com/office/drawing/2014/main" id="{7A106121-6E48-4CDF-A06D-0BB49F2BA4EC}"/>
-                  </a:ext>
-                </a:extLst>
-              </p:cNvPr>
-              <p:cNvGraphicFramePr>
-                <a:graphicFrameLocks noChangeAspect="1"/>
-              </p:cNvGraphicFramePr>
-              <p:nvPr>
-                <p:extLst>
-                  <p:ext uri="{D42A27DB-BD31-4B8C-83A1-F6EECF244321}">
-                    <p14:modId xmlns:p14="http://schemas.microsoft.com/office/powerpoint/2010/main" val="2228535216"/>
-                  </p:ext>
-                </p:extLst>
-              </p:nvPr>
-            </p:nvGraphicFramePr>
-            <p:xfrm>
-              <a:off x="3631804" y="1682255"/>
-              <a:ext cx="1880392" cy="1175245"/>
-            </p:xfrm>
-            <a:graphic>
-              <a:graphicData uri="http://schemas.microsoft.com/office/powerpoint/2016/slidezoom">
-                <pslz:sldZm>
-                  <pslz:sldZmObj sldId="283" cId="1235559135">
-                    <pslz:zmPr id="{5FD83A48-B0BC-4D99-9FD6-814863FBAD1C}" transitionDur="1000" showBg="0">
-                      <p166:blipFill xmlns:p166="http://schemas.microsoft.com/office/powerpoint/2016/6/main">
-                        <a:blip r:embed="rId2"/>
-                        <a:stretch>
-                          <a:fillRect/>
-                        </a:stretch>
-                      </p166:blipFill>
-                      <p166:spPr xmlns:p166="http://schemas.microsoft.com/office/powerpoint/2016/6/main">
-                        <a:xfrm>
-                          <a:off x="0" y="0"/>
-                          <a:ext cx="1880392" cy="1175245"/>
-                        </a:xfrm>
-                        <a:prstGeom prst="rect">
-                          <a:avLst/>
-                        </a:prstGeom>
-                      </p166:spPr>
-                    </pslz:zmPr>
-                  </pslz:sldZmObj>
-                </pslz:sldZm>
-              </a:graphicData>
-            </a:graphic>
-          </p:graphicFrame>
-        </mc:Choice>
+        <mc:Choice xmlns:pslz="http://schemas.microsoft.com/office/powerpoint/2016/slidezoom" Requires="pslz"/>
         <mc:Fallback>
           <p:pic>
             <p:nvPicPr>
@@ -14035,7 +14180,7 @@
 </p:sld>
 </file>
 
-<file path=ppt/slides/slide12.xml><?xml version="1.0" encoding="utf-8"?>
+<file path=ppt/slides/slide13.xml><?xml version="1.0" encoding="utf-8"?>
 <p:sld xmlns:a="http://schemas.openxmlformats.org/drawingml/2006/main" xmlns:r="http://schemas.openxmlformats.org/officeDocument/2006/relationships" xmlns:p="http://schemas.openxmlformats.org/presentationml/2006/main">
   <p:cSld>
     <p:spTree>
@@ -14235,7 +14380,7 @@
 </p:sld>
 </file>
 
-<file path=ppt/slides/slide13.xml><?xml version="1.0" encoding="utf-8"?>
+<file path=ppt/slides/slide14.xml><?xml version="1.0" encoding="utf-8"?>
 <p:sld xmlns:a="http://schemas.openxmlformats.org/drawingml/2006/main" xmlns:r="http://schemas.openxmlformats.org/officeDocument/2006/relationships" xmlns:p="http://schemas.openxmlformats.org/presentationml/2006/main">
   <p:cSld>
     <p:spTree>
@@ -14381,6 +14526,25 @@
               <a:p>
                 <a:pPr lvl="2"/>
                 <a:r>
+                  <a:rPr lang="en-US" i="1" dirty="0"/>
+                  <a:t>Methodology: the bonus is guaranteed; salary is discounted by (1+i)</a:t>
+                </a:r>
+                <a:r>
+                  <a:rPr lang="en-US" i="1" baseline="30000" dirty="0"/>
+                  <a:t>t</a:t>
+                </a:r>
+                <a:r>
+                  <a:rPr lang="en-US" i="1" dirty="0"/>
+                  <a:t> and compounding retention odds p</a:t>
+                </a:r>
+                <a:r>
+                  <a:rPr lang="en-US" i="1" baseline="30000" dirty="0"/>
+                  <a:t>t</a:t>
+                </a:r>
+              </a:p>
+              <a:p>
+                <a:pPr lvl="2"/>
+                <a:r>
                   <a:rPr lang="en-US" dirty="0"/>
                   <a:t>Correlation between probability of remaining in a club and market factors that influence the discount rate (</a:t>
                 </a:r>
@@ -14390,7 +14554,7 @@
                       <a:rPr lang="nb-NO" b="0" i="1" smtClean="0">
                         <a:latin typeface="Cambria Math" panose="02040503050406030204" pitchFamily="18" charset="0"/>
                       </a:rPr>
-                      <m:t>𝛿</m:t>
+                      <m:t>𝑖</m:t>
                     </m:r>
                   </m:oMath>
                 </a14:m>
@@ -14541,7 +14705,104 @@
 </p:sld>
 </file>
 
-<file path=ppt/slides/slide14.xml><?xml version="1.0" encoding="utf-8"?>
+<file path=ppt/slides/slide15.xml><?xml version="1.0" encoding="utf-8"?>
+<p:sld xmlns:a="http://schemas.openxmlformats.org/drawingml/2006/main" xmlns:p="http://schemas.openxmlformats.org/presentationml/2006/main" xmlns:r="http://schemas.openxmlformats.org/officeDocument/2006/relationships">
+  <p:cSld>
+    <p:spTree>
+      <p:nvGrpSpPr>
+        <p:cNvPr id="1" name=""/>
+        <p:cNvGrpSpPr/>
+        <p:nvPr/>
+      </p:nvGrpSpPr>
+      <p:grpSpPr/>
+      <p:sp>
+        <p:nvSpPr>
+          <p:cNvPr id="2" name="Title 1"/>
+          <p:cNvSpPr>
+            <a:spLocks noGrp="1"/>
+          </p:cNvSpPr>
+          <p:nvPr>
+            <p:ph type="title"/>
+          </p:nvPr>
+        </p:nvSpPr>
+        <p:spPr/>
+        <p:txBody>
+          <a:bodyPr/>
+          <a:lstStyle/>
+          <a:p>
+            <a:r>
+              <a:t>Worked Example — Ronde Barber, Year 3</a:t>
+            </a:r>
+          </a:p>
+        </p:txBody>
+      </p:sp>
+      <p:sp>
+        <p:nvSpPr>
+          <p:cNvPr id="3" name="Content Placeholder 2"/>
+          <p:cNvSpPr>
+            <a:spLocks noGrp="1"/>
+          </p:cNvSpPr>
+          <p:nvPr>
+            <p:ph idx="1"/>
+          </p:nvPr>
+        </p:nvSpPr>
+        <p:spPr/>
+        <p:txBody>
+          <a:bodyPr wrap="square"/>
+          <a:lstStyle/>
+          <a:p>
+            <a:pPr/>
+            <a:r>
+              <a:t>Contracted (nominal) salary in Year 3: $3,250K</a:t>
+            </a:r>
+          </a:p>
+          <a:p>
+            <a:pPr/>
+            <a:r>
+              <a:t>Step 1 — discount for time only, at i = 8%:</a:t>
+            </a:r>
+          </a:p>
+          <a:p>
+            <a:pPr lvl="1"/>
+            <a:r>
+              <a:t>PV = 3,250 / (1.08)³ = 3,250 / 1.2597 ≈ $2,580K</a:t>
+            </a:r>
+          </a:p>
+          <a:p>
+            <a:pPr/>
+            <a:r>
+              <a:t>Step 2 — weight by the compounding chance he is still on the roster in year 3, p = 0.8:</a:t>
+            </a:r>
+          </a:p>
+          <a:p>
+            <a:pPr lvl="1"/>
+            <a:r>
+              <a:t>Survival to year 3 = p³ = 0.8³ = 0.512</a:t>
+            </a:r>
+          </a:p>
+          <a:p>
+            <a:pPr lvl="1"/>
+            <a:r>
+              <a:t>Expected PV = 2,580 × 0.512 ≈ $1,321K</a:t>
+            </a:r>
+          </a:p>
+          <a:p>
+            <a:pPr/>
+            <a:r>
+              <a:t>Result: a $3,250K salary line is really worth about $1,321K today — a 59% reduction once time and retention risk are both priced in</a:t>
+            </a:r>
+          </a:p>
+        </p:txBody>
+      </p:sp>
+    </p:spTree>
+  </p:cSld>
+  <p:clrMapOvr>
+    <a:masterClrMapping/>
+  </p:clrMapOvr>
+</p:sld>
+</file>
+
+<file path=ppt/slides/slide16.xml><?xml version="1.0" encoding="utf-8"?>
 <p:sld xmlns:a="http://schemas.openxmlformats.org/drawingml/2006/main" xmlns:r="http://schemas.openxmlformats.org/officeDocument/2006/relationships" xmlns:p="http://schemas.openxmlformats.org/presentationml/2006/main">
   <p:cSld>
     <p:spTree>
@@ -14580,14 +14841,74 @@
         </p:blipFill>
         <p:spPr>
           <a:xfrm>
-            <a:off x="2453832" y="735606"/>
-            <a:ext cx="4535437" cy="4243788"/>
+            <a:off x="2488035" y="950000"/>
+            <a:ext cx="4167930" cy="3900000"/>
           </a:xfrm>
           <a:prstGeom prst="rect">
             <a:avLst/>
           </a:prstGeom>
         </p:spPr>
       </p:pic>
+      <p:sp>
+        <p:nvSpPr>
+          <p:cNvPr id="10" name="Title 1"/>
+          <p:cNvSpPr>
+            <a:spLocks noGrp="1"/>
+          </p:cNvSpPr>
+          <p:nvPr>
+            <p:ph type="title"/>
+          </p:nvPr>
+        </p:nvSpPr>
+        <p:spPr>
+          <a:xfrm>
+            <a:off x="628650" y="180000"/>
+            <a:ext cx="7886700" cy="700000"/>
+          </a:xfrm>
+        </p:spPr>
+        <p:txBody>
+          <a:bodyPr anchor="ctr"/>
+          <a:lstStyle/>
+          <a:p>
+            <a:pPr algn="ctr"/>
+            <a:r>
+              <a:rPr lang="en-US" sz="2400" dirty="0">
+                <a:solidFill>
+                  <a:schemeClr val="bg1"/>
+                </a:solidFill>
+              </a:rPr>
+              <a:t>NFL Contracts — PV vs. Expected PV</a:t>
+            </a:r>
+          </a:p>
+        </p:txBody>
+      </p:sp>
+      <p:sp>
+        <p:nvSpPr>
+          <p:cNvPr id="11" name="Caption"/>
+          <p:cNvSpPr txBox="1"/>
+          <p:nvPr/>
+        </p:nvSpPr>
+        <p:spPr>
+          <a:xfrm>
+            <a:off x="800000" y="4870000"/>
+            <a:ext cx="7544000" cy="320000"/>
+          </a:xfrm>
+          <a:prstGeom prst="rect">
+            <a:avLst/>
+          </a:prstGeom>
+          <a:noFill/>
+        </p:spPr>
+        <p:txBody>
+          <a:bodyPr wrap="square" rtlCol="0"/>
+          <a:lstStyle/>
+          <a:p>
+            <a:pPr algn="ctr"/>
+            <a:r>
+              <a:rPr lang="en-US" sz="1100" i="1" dirty="0"/>
+              <a:t>Note: "r" here denotes the same discount rate as "i" used elsewhere in this lecture.</a:t>
+            </a:r>
+          </a:p>
+        </p:txBody>
+      </p:sp>
     </p:spTree>
     <p:extLst>
       <p:ext uri="{BB962C8B-B14F-4D97-AF65-F5344CB8AC3E}">
@@ -14601,8 +14922,8 @@
 </p:sld>
 </file>
 
-<file path=ppt/slides/slide15.xml><?xml version="1.0" encoding="utf-8"?>
-<p:sld xmlns:a="http://schemas.openxmlformats.org/drawingml/2006/main" xmlns:r="http://schemas.openxmlformats.org/officeDocument/2006/relationships" xmlns:p="http://schemas.openxmlformats.org/presentationml/2006/main">
+<file path=ppt/slides/slide17.xml><?xml version="1.0" encoding="utf-8"?>
+<p:sld xmlns:a="http://schemas.openxmlformats.org/drawingml/2006/main" xmlns:p="http://schemas.openxmlformats.org/presentationml/2006/main" xmlns:r="http://schemas.openxmlformats.org/officeDocument/2006/relationships">
   <p:cSld>
     <p:spTree>
       <p:nvGrpSpPr>
@@ -14610,39 +14931,46 @@
         <p:cNvGrpSpPr/>
         <p:nvPr/>
       </p:nvGrpSpPr>
-      <p:grpSpPr>
-        <a:xfrm>
-          <a:off x="0" y="0"/>
-          <a:ext cx="0" cy="0"/>
-          <a:chOff x="0" y="0"/>
-          <a:chExt cx="0" cy="0"/>
-        </a:xfrm>
-      </p:grpSpPr>
+      <p:grpSpPr/>
+      <p:sp>
+        <p:nvSpPr>
+          <p:cNvPr id="2" name="Title 1"/>
+          <p:cNvSpPr>
+            <a:spLocks noGrp="1"/>
+          </p:cNvSpPr>
+          <p:nvPr>
+            <p:ph type="title"/>
+          </p:nvPr>
+        </p:nvSpPr>
+        <p:spPr/>
+        <p:txBody>
+          <a:bodyPr/>
+          <a:lstStyle/>
+          <a:p>
+            <a:r>
+              <a:t>Sensitivity — How Much Does the Discount Rate Matter?</a:t>
+            </a:r>
+          </a:p>
+        </p:txBody>
+      </p:sp>
       <p:pic>
         <p:nvPicPr>
-          <p:cNvPr id="3" name="Picture 2">
-            <a:hlinkClick r:id="rId2"/>
-            <a:extLst>
-              <a:ext uri="{FF2B5EF4-FFF2-40B4-BE49-F238E27FC236}">
-                <a16:creationId xmlns:a16="http://schemas.microsoft.com/office/drawing/2014/main" id="{C6FDEF4D-DD92-4DE7-9A93-D7A3F0785557}"/>
-              </a:ext>
-            </a:extLst>
-          </p:cNvPr>
+          <p:cNvPr id="3" name="Picture 2" descr="sensitivity_chart.png"/>
           <p:cNvPicPr>
             <a:picLocks noChangeAspect="1"/>
           </p:cNvPicPr>
           <p:nvPr/>
         </p:nvPicPr>
         <p:blipFill>
-          <a:blip r:embed="rId3"/>
+          <a:blip r:embed="rId2"/>
           <a:stretch>
             <a:fillRect/>
           </a:stretch>
         </p:blipFill>
         <p:spPr>
           <a:xfrm>
-            <a:off x="689887" y="1137997"/>
-            <a:ext cx="8002117" cy="3439005"/>
+            <a:off x="2193428" y="1250000"/>
+            <a:ext cx="4757143" cy="3600000"/>
           </a:xfrm>
           <a:prstGeom prst="rect">
             <a:avLst/>
@@ -14650,11 +14978,188 @@
         </p:spPr>
       </p:pic>
     </p:spTree>
-    <p:extLst>
-      <p:ext uri="{BB962C8B-B14F-4D97-AF65-F5344CB8AC3E}">
-        <p14:creationId xmlns:p14="http://schemas.microsoft.com/office/powerpoint/2010/main" val="2402026329"/>
-      </p:ext>
-    </p:extLst>
+  </p:cSld>
+  <p:clrMapOvr>
+    <a:masterClrMapping/>
+  </p:clrMapOvr>
+</p:sld>
+</file>
+
+<file path=ppt/slides/slide18.xml><?xml version="1.0" encoding="utf-8"?>
+<p:sld xmlns:a="http://schemas.openxmlformats.org/drawingml/2006/main" xmlns:p="http://schemas.openxmlformats.org/presentationml/2006/main" xmlns:r="http://schemas.openxmlformats.org/officeDocument/2006/relationships">
+  <p:cSld>
+    <p:spTree>
+      <p:nvGrpSpPr>
+        <p:cNvPr id="1" name=""/>
+        <p:cNvGrpSpPr/>
+        <p:nvPr/>
+      </p:nvGrpSpPr>
+      <p:grpSpPr/>
+      <p:sp>
+        <p:nvSpPr>
+          <p:cNvPr id="2" name="Title 1"/>
+          <p:cNvSpPr>
+            <a:spLocks noGrp="1"/>
+          </p:cNvSpPr>
+          <p:nvPr>
+            <p:ph type="title"/>
+          </p:nvPr>
+        </p:nvSpPr>
+        <p:spPr/>
+        <p:txBody>
+          <a:bodyPr/>
+          <a:lstStyle/>
+          <a:p>
+            <a:r>
+              <a:t>Guaranteed vs. Non-Guaranteed Contracts — NFL vs. NBA</a:t>
+            </a:r>
+          </a:p>
+        </p:txBody>
+      </p:sp>
+      <p:sp>
+        <p:nvSpPr>
+          <p:cNvPr id="3" name="Content Placeholder 2"/>
+          <p:cNvSpPr>
+            <a:spLocks noGrp="1"/>
+          </p:cNvSpPr>
+          <p:nvPr>
+            <p:ph idx="1"/>
+          </p:nvPr>
+        </p:nvSpPr>
+        <p:spPr/>
+        <p:txBody>
+          <a:bodyPr wrap="square"/>
+          <a:lstStyle/>
+          <a:p>
+            <a:pPr/>
+            <a:r>
+              <a:t>NFL: contracts are mostly not guaranteed — a cut player forfeits future salary (keeps only the bonus, per the earlier slide)</a:t>
+            </a:r>
+          </a:p>
+          <a:p>
+            <a:pPr/>
+            <a:r>
+              <a:t>NBA (from Lecture 8): contracts are fully guaranteed — salary is owed even if the player is cut, so p = 1 and only time is discounted</a:t>
+            </a:r>
+          </a:p>
+          <a:p>
+            <a:pPr/>
+            <a:r>
+              <a:t>Same nominal salary → higher expected value under a guaranteed contract</a:t>
+            </a:r>
+          </a:p>
+          <a:p>
+            <a:pPr/>
+            <a:r>
+              <a:t>Ronde Barber, at i = 8%:</a:t>
+            </a:r>
+          </a:p>
+          <a:p>
+            <a:pPr lvl="1"/>
+            <a:r>
+              <a:t>NFL-style (p = 0.8): Expected PV = $7,118K</a:t>
+            </a:r>
+          </a:p>
+          <a:p>
+            <a:pPr lvl="1"/>
+            <a:r>
+              <a:t>If fully guaranteed, NBA-style (p = 1): PV = $13,826K — about 94% more, for the exact same salary numbers</a:t>
+            </a:r>
+          </a:p>
+          <a:p>
+            <a:pPr/>
+            <a:r>
+              <a:t>Guarantee structure is itself a form of value — not just the dollar amount on paper</a:t>
+            </a:r>
+          </a:p>
+        </p:txBody>
+      </p:sp>
+    </p:spTree>
+  </p:cSld>
+  <p:clrMapOvr>
+    <a:masterClrMapping/>
+  </p:clrMapOvr>
+</p:sld>
+</file>
+
+<file path=ppt/slides/slide19.xml><?xml version="1.0" encoding="utf-8"?>
+<p:sld xmlns:a="http://schemas.openxmlformats.org/drawingml/2006/main" xmlns:p="http://schemas.openxmlformats.org/presentationml/2006/main" xmlns:r="http://schemas.openxmlformats.org/officeDocument/2006/relationships">
+  <p:cSld>
+    <p:spTree>
+      <p:nvGrpSpPr>
+        <p:cNvPr id="1" name=""/>
+        <p:cNvGrpSpPr/>
+        <p:nvPr/>
+      </p:nvGrpSpPr>
+      <p:grpSpPr/>
+      <p:sp>
+        <p:nvSpPr>
+          <p:cNvPr id="2" name="Title 1"/>
+          <p:cNvSpPr>
+            <a:spLocks noGrp="1"/>
+          </p:cNvSpPr>
+          <p:nvPr>
+            <p:ph type="title"/>
+          </p:nvPr>
+        </p:nvSpPr>
+        <p:spPr/>
+        <p:txBody>
+          <a:bodyPr/>
+          <a:lstStyle/>
+          <a:p>
+            <a:r>
+              <a:t>Key Takeaways</a:t>
+            </a:r>
+          </a:p>
+        </p:txBody>
+      </p:sp>
+      <p:sp>
+        <p:nvSpPr>
+          <p:cNvPr id="3" name="Content Placeholder 2"/>
+          <p:cNvSpPr>
+            <a:spLocks noGrp="1"/>
+          </p:cNvSpPr>
+          <p:nvPr>
+            <p:ph idx="1"/>
+          </p:nvPr>
+        </p:nvSpPr>
+        <p:spPr/>
+        <p:txBody>
+          <a:bodyPr wrap="square"/>
+          <a:lstStyle/>
+          <a:p>
+            <a:pPr/>
+            <a:r>
+              <a:t>Money today is worth more than the same money tomorrow — always discount future cash flows before comparing them</a:t>
+            </a:r>
+          </a:p>
+          <a:p>
+            <a:pPr/>
+            <a:r>
+              <a:t>Discount rate (i) ≠ inflation (π) — related but distinct concepts</a:t>
+            </a:r>
+          </a:p>
+          <a:p>
+            <a:pPr/>
+            <a:r>
+              <a:t>A contract’s reported (nominal) value overstates its true worth once you account for both time and risk</a:t>
+            </a:r>
+          </a:p>
+          <a:p>
+            <a:pPr/>
+            <a:r>
+              <a:t>Expected PV = discount for time, (1+i)ᵗ, AND for the probability the cash flow actually happens, pᵗ</a:t>
+            </a:r>
+          </a:p>
+          <a:p>
+            <a:pPr/>
+            <a:r>
+              <a:t>Whether a cash flow is guaranteed changes its value — before you’ve even factored in risk aversion</a:t>
+            </a:r>
+          </a:p>
+        </p:txBody>
+      </p:sp>
+    </p:spTree>
   </p:cSld>
   <p:clrMapOvr>
     <a:masterClrMapping/>
@@ -15260,8 +15765,8 @@
               </p:nvPr>
             </p:nvGraphicFramePr>
             <p:xfrm>
-              <a:off x="5240294" y="2490366"/>
-              <a:ext cx="3275056" cy="2046910"/>
+              <a:off x="4950000" y="2300000"/>
+              <a:ext cx="4194000" cy="2620000"/>
             </p:xfrm>
             <a:graphic>
               <a:graphicData uri="http://schemas.microsoft.com/office/powerpoint/2016/slidezoom">
@@ -15346,8 +15851,8 @@
               </p:nvPr>
             </p:nvGraphicFramePr>
             <p:xfrm>
-              <a:off x="1927330" y="3343841"/>
-              <a:ext cx="2286000" cy="1428750"/>
+              <a:off x="1400000" y="3050000"/>
+              <a:ext cx="3200000" cy="2000000"/>
             </p:xfrm>
             <a:graphic>
               <a:graphicData uri="http://schemas.microsoft.com/office/powerpoint/2016/slidezoom">
@@ -15958,6 +16463,97 @@
 </file>
 
 <file path=ppt/slides/slide7.xml><?xml version="1.0" encoding="utf-8"?>
+<p:sld xmlns:a="http://schemas.openxmlformats.org/drawingml/2006/main" xmlns:p="http://schemas.openxmlformats.org/presentationml/2006/main" xmlns:r="http://schemas.openxmlformats.org/officeDocument/2006/relationships">
+  <p:cSld>
+    <p:spTree>
+      <p:nvGrpSpPr>
+        <p:cNvPr id="1" name=""/>
+        <p:cNvGrpSpPr/>
+        <p:nvPr/>
+      </p:nvGrpSpPr>
+      <p:grpSpPr/>
+      <p:sp>
+        <p:nvSpPr>
+          <p:cNvPr id="2" name="Title 1"/>
+          <p:cNvSpPr>
+            <a:spLocks noGrp="1"/>
+          </p:cNvSpPr>
+          <p:nvPr>
+            <p:ph type="title"/>
+          </p:nvPr>
+        </p:nvSpPr>
+        <p:spPr/>
+        <p:txBody>
+          <a:bodyPr/>
+          <a:lstStyle/>
+          <a:p>
+            <a:r>
+              <a:t>PV of Multiple Cash Flows — The Annuity Formula</a:t>
+            </a:r>
+          </a:p>
+        </p:txBody>
+      </p:sp>
+      <p:sp>
+        <p:nvSpPr>
+          <p:cNvPr id="3" name="Content Placeholder 2"/>
+          <p:cNvSpPr>
+            <a:spLocks noGrp="1"/>
+          </p:cNvSpPr>
+          <p:nvPr>
+            <p:ph idx="1"/>
+          </p:nvPr>
+        </p:nvSpPr>
+        <p:spPr/>
+        <p:txBody>
+          <a:bodyPr wrap="square"/>
+          <a:lstStyle/>
+          <a:p>
+            <a:pPr/>
+            <a:r>
+              <a:t>A contract is not a single payment — it is a stream of cash flows spread over several years</a:t>
+            </a:r>
+          </a:p>
+          <a:p>
+            <a:pPr/>
+            <a:r>
+              <a:t>Extend the single-payment PV formula by discounting and summing each year’s cash flow separately:</a:t>
+            </a:r>
+          </a:p>
+          <a:p>
+            <a:pPr lvl="1"/>
+            <a:r>
+              <a:t>PV = Σ CFₜ / (1+i)ᵗ   (t = 1 to n)</a:t>
+            </a:r>
+          </a:p>
+          <a:p>
+            <a:pPr lvl="1"/>
+            <a:r>
+              <a:t>CFₜ = the cash flow in year t (e.g. that year’s salary)</a:t>
+            </a:r>
+          </a:p>
+          <a:p>
+            <a:pPr lvl="1"/>
+            <a:r>
+              <a:t>Every term uses the same discount rate i, but a different exponent t — later cash flows get discounted more</a:t>
+            </a:r>
+          </a:p>
+          <a:p>
+            <a:pPr/>
+            <a:r>
+              <a:t>This is exactly what the NFL contract table (coming up) applies year-by-year to each player’s salary</a:t>
+            </a:r>
+          </a:p>
+        </p:txBody>
+      </p:sp>
+    </p:spTree>
+  </p:cSld>
+  <p:clrMapOvr>
+    <a:masterClrMapping/>
+  </p:clrMapOvr>
+</p:sld>
+</file>
+
+<file path=ppt/slides/slide8.xml><?xml version="1.0" encoding="utf-8"?>
 <p:sld xmlns:a="http://schemas.openxmlformats.org/drawingml/2006/main" xmlns:r="http://schemas.openxmlformats.org/officeDocument/2006/relationships" xmlns:p="http://schemas.openxmlformats.org/presentationml/2006/main">
   <p:cSld>
     <p:spTree>
@@ -16070,7 +16666,7 @@
             <a:pPr lvl="2"/>
             <a:r>
               <a:rPr lang="it-IT" dirty="0"/>
-              <a:t>Difference between the present cash flows and the PV of cash flows over a period of time</a:t>
+              <a:t>The sum of the present values of expected future cash flows, minus the initial cost of the investment</a:t>
             </a:r>
           </a:p>
           <a:p>
@@ -16116,7 +16712,7 @@
 </p:sld>
 </file>
 
-<file path=ppt/slides/slide8.xml><?xml version="1.0" encoding="utf-8"?>
+<file path=ppt/slides/slide9.xml><?xml version="1.0" encoding="utf-8"?>
 <p:sld xmlns:a="http://schemas.openxmlformats.org/drawingml/2006/main" xmlns:r="http://schemas.openxmlformats.org/officeDocument/2006/relationships" xmlns:p="http://schemas.openxmlformats.org/presentationml/2006/main">
   <p:cSld>
     <p:spTree>
@@ -16277,8 +16873,8 @@
               </p:nvPr>
             </p:nvGraphicFramePr>
             <p:xfrm>
-              <a:off x="4942025" y="1622145"/>
-              <a:ext cx="1143000" cy="714375"/>
+              <a:off x="8150000" y="2450000"/>
+              <a:ext cx="900000" cy="562500"/>
             </p:xfrm>
             <a:graphic>
               <a:graphicData uri="http://schemas.microsoft.com/office/powerpoint/2016/slidezoom">
@@ -16354,206 +16950,6 @@
     <p:extLst>
       <p:ext uri="{BB962C8B-B14F-4D97-AF65-F5344CB8AC3E}">
         <p14:creationId xmlns:p14="http://schemas.microsoft.com/office/powerpoint/2010/main" val="4039083811"/>
-      </p:ext>
-    </p:extLst>
-  </p:cSld>
-  <p:clrMapOvr>
-    <a:masterClrMapping/>
-  </p:clrMapOvr>
-</p:sld>
-</file>
-
-<file path=ppt/slides/slide9.xml><?xml version="1.0" encoding="utf-8"?>
-<p:sld xmlns:a="http://schemas.openxmlformats.org/drawingml/2006/main" xmlns:r="http://schemas.openxmlformats.org/officeDocument/2006/relationships" xmlns:p="http://schemas.openxmlformats.org/presentationml/2006/main">
-  <p:cSld>
-    <p:spTree>
-      <p:nvGrpSpPr>
-        <p:cNvPr id="1" name=""/>
-        <p:cNvGrpSpPr/>
-        <p:nvPr/>
-      </p:nvGrpSpPr>
-      <p:grpSpPr>
-        <a:xfrm>
-          <a:off x="0" y="0"/>
-          <a:ext cx="0" cy="0"/>
-          <a:chOff x="0" y="0"/>
-          <a:chExt cx="0" cy="0"/>
-        </a:xfrm>
-      </p:grpSpPr>
-      <mc:AlternateContent xmlns:mc="http://schemas.openxmlformats.org/markup-compatibility/2006" xmlns:a14="http://schemas.microsoft.com/office/drawing/2010/main">
-        <mc:Choice Requires="a14">
-          <p:sp>
-            <p:nvSpPr>
-              <p:cNvPr id="2" name="Title 1">
-                <a:extLst>
-                  <a:ext uri="{FF2B5EF4-FFF2-40B4-BE49-F238E27FC236}">
-                    <a16:creationId xmlns:a16="http://schemas.microsoft.com/office/drawing/2014/main" id="{B21B660B-1E0B-4D01-87CB-4B7D98486F54}"/>
-                  </a:ext>
-                </a:extLst>
-              </p:cNvPr>
-              <p:cNvSpPr>
-                <a:spLocks noGrp="1"/>
-              </p:cNvSpPr>
-              <p:nvPr>
-                <p:ph type="title"/>
-              </p:nvPr>
-            </p:nvSpPr>
-            <p:spPr/>
-            <p:txBody>
-              <a:bodyPr/>
-              <a:lstStyle/>
-              <a:p>
-                <a:pPr algn="ctr"/>
-                <a:r>
-                  <a:rPr lang="it-IT" dirty="0"/>
-                  <a:t>Inflation rate (</a:t>
-                </a:r>
-                <a14:m>
-                  <m:oMath xmlns:m="http://schemas.openxmlformats.org/officeDocument/2006/math">
-                    <m:r>
-                      <a:rPr lang="nb-NO" b="0" i="1" smtClean="0">
-                        <a:latin typeface="Cambria Math" panose="02040503050406030204" pitchFamily="18" charset="0"/>
-                      </a:rPr>
-                      <m:t>𝜋</m:t>
-                    </m:r>
-                    <m:r>
-                      <a:rPr lang="nb-NO" b="0" i="1" smtClean="0">
-                        <a:latin typeface="Cambria Math" panose="02040503050406030204" pitchFamily="18" charset="0"/>
-                      </a:rPr>
-                      <m:t>)</m:t>
-                    </m:r>
-                  </m:oMath>
-                </a14:m>
-                <a:r>
-                  <a:rPr lang="en-US" dirty="0"/>
-                  <a:t> Norway</a:t>
-                </a:r>
-              </a:p>
-            </p:txBody>
-          </p:sp>
-        </mc:Choice>
-        <mc:Fallback xmlns="">
-          <p:sp>
-            <p:nvSpPr>
-              <p:cNvPr id="2" name="Title 1">
-                <a:extLst>
-                  <a:ext uri="{FF2B5EF4-FFF2-40B4-BE49-F238E27FC236}">
-                    <a16:creationId xmlns:a16="http://schemas.microsoft.com/office/drawing/2014/main" id="{B21B660B-1E0B-4D01-87CB-4B7D98486F54}"/>
-                  </a:ext>
-                </a:extLst>
-              </p:cNvPr>
-              <p:cNvSpPr>
-                <a:spLocks noGrp="1" noRot="1" noChangeAspect="1" noMove="1" noResize="1" noEditPoints="1" noAdjustHandles="1" noChangeArrowheads="1" noChangeShapeType="1" noTextEdit="1"/>
-              </p:cNvSpPr>
-              <p:nvPr>
-                <p:ph type="title"/>
-              </p:nvPr>
-            </p:nvSpPr>
-            <p:spPr>
-              <a:blipFill>
-                <a:blip r:embed="rId2"/>
-                <a:stretch>
-                  <a:fillRect/>
-                </a:stretch>
-              </a:blipFill>
-            </p:spPr>
-            <p:txBody>
-              <a:bodyPr/>
-              <a:lstStyle/>
-              <a:p>
-                <a:r>
-                  <a:rPr lang="en-US">
-                    <a:noFill/>
-                  </a:rPr>
-                  <a:t> </a:t>
-                </a:r>
-              </a:p>
-            </p:txBody>
-          </p:sp>
-        </mc:Fallback>
-      </mc:AlternateContent>
-      <p:sp>
-        <p:nvSpPr>
-          <p:cNvPr id="3" name="Content Placeholder 2">
-            <a:extLst>
-              <a:ext uri="{FF2B5EF4-FFF2-40B4-BE49-F238E27FC236}">
-                <a16:creationId xmlns:a16="http://schemas.microsoft.com/office/drawing/2014/main" id="{6285D6BC-086B-479F-9F72-15CA362D665B}"/>
-              </a:ext>
-            </a:extLst>
-          </p:cNvPr>
-          <p:cNvSpPr>
-            <a:spLocks noGrp="1"/>
-          </p:cNvSpPr>
-          <p:nvPr>
-            <p:ph idx="1"/>
-          </p:nvPr>
-        </p:nvSpPr>
-        <p:spPr/>
-        <p:txBody>
-          <a:bodyPr>
-            <a:normAutofit/>
-          </a:bodyPr>
-          <a:lstStyle/>
-          <a:p>
-            <a:r>
-              <a:rPr lang="en-US" sz="2000" dirty="0"/>
-              <a:t>Inflation is a general increase in the price level of goods and services in the economy over time</a:t>
-            </a:r>
-          </a:p>
-          <a:p>
-            <a:pPr lvl="1"/>
-            <a:r>
-              <a:rPr lang="en-US" sz="1800" dirty="0"/>
-              <a:t>Inflation </a:t>
-            </a:r>
-            <a:r>
-              <a:rPr lang="en-US" sz="1800" dirty="0">
-                <a:sym typeface="Wingdings" panose="05000000000000000000" pitchFamily="2" charset="2"/>
-              </a:rPr>
-              <a:t>   future price of goods </a:t>
-            </a:r>
-            <a:endParaRPr lang="en-US" sz="1800" dirty="0"/>
-          </a:p>
-          <a:p>
-            <a:r>
-              <a:rPr lang="en-US" sz="2000" dirty="0"/>
-              <a:t>September 2021 4.1% - August 2021 3.4%</a:t>
-            </a:r>
-          </a:p>
-          <a:p>
-            <a:pPr lvl="1"/>
-            <a:r>
-              <a:rPr lang="en-US" sz="2000" dirty="0"/>
-              <a:t>Highest inflation rate since July 2016</a:t>
-            </a:r>
-          </a:p>
-          <a:p>
-            <a:pPr lvl="2"/>
-            <a:r>
-              <a:rPr lang="en-US" sz="2000" dirty="0"/>
-              <a:t>Faster rise in prices of housing and utilities </a:t>
-            </a:r>
-          </a:p>
-          <a:p>
-            <a:pPr lvl="2"/>
-            <a:r>
-              <a:rPr lang="en-US" sz="2000" dirty="0"/>
-              <a:t>Furnishing household equipment and routine maintenance</a:t>
-            </a:r>
-          </a:p>
-          <a:p>
-            <a:pPr lvl="2"/>
-            <a:r>
-              <a:rPr lang="en-US" sz="2000" dirty="0"/>
-              <a:t>Recreation and culture</a:t>
-            </a:r>
-          </a:p>
-        </p:txBody>
-      </p:sp>
-    </p:spTree>
-    <p:extLst>
-      <p:ext uri="{BB962C8B-B14F-4D97-AF65-F5344CB8AC3E}">
-        <p14:creationId xmlns:p14="http://schemas.microsoft.com/office/powerpoint/2010/main" val="2310254051"/>
       </p:ext>
     </p:extLst>
   </p:cSld>

</xml_diff>